<commit_message>
docs(week05): remove outdated Week 03 references and align baseline strictly to Week 04 & Milestone 1
</commit_message>
<xml_diff>
--- a/docs/week05/UC8_Week05_Milestone1_Presentation.pptx
+++ b/docs/week05/UC8_Week05_Milestone1_Presentation.pptx
@@ -8570,7 +8570,7 @@
               </a:defRPr>
             </a:pPr>
             <a:r>
-              <a:t>• All commitments made from Week 03 have been 100% fulfilled and reinforced with faculty feedback solutions.</a:t>
+              <a:t>• All commitments made for Milestone 1 have been 100% fulfilled and reinforced with faculty feedback solutions.</a:t>
             </a:r>
             <a:br/>
             <a:r>
@@ -9048,7 +9048,7 @@
                         </a:defRPr>
                       </a:pPr>
                       <a:r>
-                        <a:t>100% completion of Week 03 commitments (R1-R4)</a:t>
+                        <a:t>100% completion of Milestone 1 commitments (R1-R4)</a:t>
                       </a:r>
                     </a:p>
                   </a:txBody>
@@ -9643,7 +9643,7 @@
               </a:defRPr>
             </a:pPr>
             <a:r>
-              <a:t>Week 03 Baseline and Commitments Set Out for Milestone 1</a:t>
+              <a:t>Week 04 Baseline and Commitments Set Out for Milestone 1</a:t>
             </a:r>
           </a:p>
         </p:txBody>
@@ -9884,7 +9884,7 @@
               </a:defRPr>
             </a:pPr>
             <a:r>
-              <a:t>Baseline Achieved in Week 03</a:t>
+              <a:t>Baseline Achieved in Week 04</a:t>
             </a:r>
           </a:p>
           <a:p>

</xml_diff>

<commit_message>
docs(week05): update Milestone 1 slides with Trajectory Visualizer [T] feature and log recent trials
</commit_message>
<xml_diff>
--- a/docs/week05/UC8_Week05_Milestone1_Presentation.pptx
+++ b/docs/week05/UC8_Week05_Milestone1_Presentation.pptx
@@ -8443,7 +8443,7 @@
               </a:defRPr>
             </a:pPr>
             <a:r>
-              <a:t>✔ Complete trials.csv QA Evidence</a:t>
+              <a:t>✔ Interactive Trajectory Trail [T]</a:t>
             </a:r>
           </a:p>
           <a:p>
@@ -8458,7 +8458,7 @@
               </a:defRPr>
             </a:pPr>
             <a:r>
-              <a:t>✔ Clean run_workcell.sh Launcher</a:t>
+              <a:t>✔ Complete trials.csv QA Evidence</a:t>
             </a:r>
           </a:p>
           <a:p>
@@ -9261,7 +9261,7 @@
                         </a:defRPr>
                       </a:pPr>
                       <a:r>
-                        <a:t>Option 1 bilateral symmetry, 90° wrist lock, pure base SCARA sweep</a:t>
+                        <a:t>Option 1 bilateral symmetry, 90° wrist lock, and Interactive Trajectory [T]</a:t>
                       </a:r>
                     </a:p>
                   </a:txBody>
@@ -10688,11 +10688,11 @@
           <a:p>
             <a:pPr>
               <a:spcAft>
-                <a:spcPts val="800"/>
+                <a:spcPts val="600"/>
               </a:spcAft>
             </a:pPr>
             <a:r>
-              <a:rPr b="1" sz="1100">
+              <a:rPr b="1" sz="1000">
                 <a:solidFill>
                   <a:srgbClr val="0F2B48"/>
                 </a:solidFill>
@@ -10700,7 +10700,7 @@
               <a:t>⚙ Kinematic Optimization: </a:t>
             </a:r>
             <a:r>
-              <a:rPr sz="1100">
+              <a:rPr sz="1000">
                 <a:solidFill>
                   <a:srgbClr val="1E293B"/>
                 </a:solidFill>
@@ -10711,11 +10711,34 @@
           <a:p>
             <a:pPr>
               <a:spcAft>
-                <a:spcPts val="800"/>
+                <a:spcPts val="600"/>
               </a:spcAft>
             </a:pPr>
             <a:r>
-              <a:rPr b="1" sz="1100">
+              <a:rPr b="1" sz="1000">
+                <a:solidFill>
+                  <a:srgbClr val="0F2B48"/>
+                </a:solidFill>
+              </a:rPr>
+              <a:t>⚙ Interactive Trajectory Trail [T]: </a:t>
+            </a:r>
+            <a:r>
+              <a:rPr sz="1000">
+                <a:solidFill>
+                  <a:srgbClr val="1E293B"/>
+                </a:solidFill>
+              </a:rPr>
+              <a:t>Implemented real-time neon ribbon visualizer at tool0 with 3.5s auto-fade and color-coded destination paths.</a:t>
+            </a:r>
+          </a:p>
+          <a:p>
+            <a:pPr>
+              <a:spcAft>
+                <a:spcPts val="600"/>
+              </a:spcAft>
+            </a:pPr>
+            <a:r>
+              <a:rPr b="1" sz="1000">
                 <a:solidFill>
                   <a:srgbClr val="0F2B48"/>
                 </a:solidFill>
@@ -10723,7 +10746,7 @@
               <a:t>⚙ Realistic PhysX Deceleration: </a:t>
             </a:r>
             <a:r>
-              <a:rPr sz="1100">
+              <a:rPr sz="1000">
                 <a:solidFill>
                   <a:srgbClr val="1E293B"/>
                 </a:solidFill>
@@ -10734,11 +10757,11 @@
           <a:p>
             <a:pPr>
               <a:spcAft>
-                <a:spcPts val="800"/>
+                <a:spcPts val="600"/>
               </a:spcAft>
             </a:pPr>
             <a:r>
-              <a:rPr b="1" sz="1100">
+              <a:rPr b="1" sz="1000">
                 <a:solidFill>
                   <a:srgbClr val="0F2B48"/>
                 </a:solidFill>
@@ -10746,7 +10769,7 @@
               <a:t>⚙ Continuous Multi-Item Flow: </a:t>
             </a:r>
             <a:r>
-              <a:rPr sz="1100">
+              <a:rPr sz="1000">
                 <a:solidFill>
                   <a:srgbClr val="1E293B"/>
                 </a:solidFill>
@@ -10757,11 +10780,11 @@
           <a:p>
             <a:pPr>
               <a:spcAft>
-                <a:spcPts val="800"/>
+                <a:spcPts val="600"/>
               </a:spcAft>
             </a:pPr>
             <a:r>
-              <a:rPr b="1" sz="1100">
+              <a:rPr b="1" sz="1000">
                 <a:solidFill>
                   <a:srgbClr val="0F2B48"/>
                 </a:solidFill>
@@ -10769,7 +10792,7 @@
               <a:t>⚙ Empirical QA Logging: </a:t>
             </a:r>
             <a:r>
-              <a:rPr sz="1100">
+              <a:rPr sz="1000">
                 <a:solidFill>
                   <a:srgbClr val="1E293B"/>
                 </a:solidFill>
@@ -13411,7 +13434,7 @@
               </a:defRPr>
             </a:pPr>
             <a:r>
-              <a:t>KINEMATICS</a:t>
+              <a:t>KINEMATICS &amp; TRAJECTORY</a:t>
             </a:r>
           </a:p>
         </p:txBody>
@@ -13446,7 +13469,7 @@
               </a:defRPr>
             </a:pPr>
             <a:r>
-              <a:t>Downward Wrist Orientation and Transfer Motion</a:t>
+              <a:t>Downward Wrist Lock, Transfer Motion &amp; Trajectory Trail</a:t>
             </a:r>
           </a:p>
         </p:txBody>
@@ -13616,7 +13639,7 @@
         <p:spPr>
           <a:xfrm>
             <a:off x="731520" y="1444752"/>
-            <a:ext cx="5212080" cy="4663440"/>
+            <a:ext cx="5212080" cy="3474720"/>
           </a:xfrm>
           <a:prstGeom prst="roundRect">
             <a:avLst>
@@ -13662,8 +13685,8 @@
         </p:nvSpPr>
         <p:spPr>
           <a:xfrm>
-            <a:off x="960120" y="1645920"/>
-            <a:ext cx="4754880" cy="4297680"/>
+            <a:off x="960120" y="1600200"/>
+            <a:ext cx="4754880" cy="3154680"/>
           </a:xfrm>
           <a:prstGeom prst="rect">
             <a:avLst/>
@@ -13678,7 +13701,7 @@
           <a:p>
             <a:pPr>
               <a:spcAft>
-                <a:spcPts val="1200"/>
+                <a:spcPts val="800"/>
               </a:spcAft>
               <a:defRPr sz="1400" b="1">
                 <a:solidFill>
@@ -13693,11 +13716,11 @@
           <a:p>
             <a:pPr>
               <a:spcAft>
-                <a:spcPts val="800"/>
+                <a:spcPts val="400"/>
               </a:spcAft>
             </a:pPr>
             <a:r>
-              <a:rPr b="1" sz="1100">
+              <a:rPr b="1" sz="1000">
                 <a:solidFill>
                   <a:srgbClr val="0F2B48"/>
                 </a:solidFill>
@@ -13705,7 +13728,7 @@
               <a:t>✔ Downward tool orientation: </a:t>
             </a:r>
             <a:r>
-              <a:rPr sz="1100">
+              <a:rPr sz="1000">
                 <a:solidFill>
                   <a:srgbClr val="1E293B"/>
                 </a:solidFill>
@@ -13716,11 +13739,11 @@
           <a:p>
             <a:pPr>
               <a:spcAft>
-                <a:spcPts val="800"/>
+                <a:spcPts val="400"/>
               </a:spcAft>
             </a:pPr>
             <a:r>
-              <a:rPr b="1" sz="1100">
+              <a:rPr b="1" sz="1000">
                 <a:solidFill>
                   <a:srgbClr val="0F2B48"/>
                 </a:solidFill>
@@ -13728,7 +13751,7 @@
               <a:t>✔ Pre-grasp waypoint: </a:t>
             </a:r>
             <a:r>
-              <a:rPr sz="1100">
+              <a:rPr sz="1000">
                 <a:solidFill>
                   <a:srgbClr val="1E293B"/>
                 </a:solidFill>
@@ -13739,11 +13762,11 @@
           <a:p>
             <a:pPr>
               <a:spcAft>
-                <a:spcPts val="800"/>
+                <a:spcPts val="400"/>
               </a:spcAft>
             </a:pPr>
             <a:r>
-              <a:rPr b="1" sz="1100">
+              <a:rPr b="1" sz="1000">
                 <a:solidFill>
                   <a:srgbClr val="0F2B48"/>
                 </a:solidFill>
@@ -13751,7 +13774,7 @@
               <a:t>✔ Vertical descent: </a:t>
             </a:r>
             <a:r>
-              <a:rPr sz="1100">
+              <a:rPr sz="1000">
                 <a:solidFill>
                   <a:srgbClr val="1E293B"/>
                 </a:solidFill>
@@ -13762,11 +13785,11 @@
           <a:p>
             <a:pPr>
               <a:spcAft>
-                <a:spcPts val="800"/>
+                <a:spcPts val="400"/>
               </a:spcAft>
             </a:pPr>
             <a:r>
-              <a:rPr b="1" sz="1100">
+              <a:rPr b="1" sz="1000">
                 <a:solidFill>
                   <a:srgbClr val="0F2B48"/>
                 </a:solidFill>
@@ -13774,7 +13797,7 @@
               <a:t>✔ Lift before transfer: </a:t>
             </a:r>
             <a:r>
-              <a:rPr sz="1100">
+              <a:rPr sz="1000">
                 <a:solidFill>
                   <a:srgbClr val="1E293B"/>
                 </a:solidFill>
@@ -13785,11 +13808,11 @@
           <a:p>
             <a:pPr>
               <a:spcAft>
-                <a:spcPts val="800"/>
+                <a:spcPts val="400"/>
               </a:spcAft>
             </a:pPr>
             <a:r>
-              <a:rPr b="1" sz="1100">
+              <a:rPr b="1" sz="1000">
                 <a:solidFill>
                   <a:srgbClr val="0F2B48"/>
                 </a:solidFill>
@@ -13797,7 +13820,7 @@
               <a:t>✔ Dominant shoulder pan: </a:t>
             </a:r>
             <a:r>
-              <a:rPr sz="1100">
+              <a:rPr sz="1000">
                 <a:solidFill>
                   <a:srgbClr val="1E293B"/>
                 </a:solidFill>
@@ -13816,7 +13839,7 @@
         <p:spPr>
           <a:xfrm>
             <a:off x="6217920" y="1444752"/>
-            <a:ext cx="5212080" cy="4663440"/>
+            <a:ext cx="5212080" cy="3474720"/>
           </a:xfrm>
           <a:prstGeom prst="roundRect">
             <a:avLst>
@@ -13862,8 +13885,8 @@
         </p:nvSpPr>
         <p:spPr>
           <a:xfrm>
-            <a:off x="6446520" y="1645920"/>
-            <a:ext cx="4754880" cy="4297680"/>
+            <a:off x="6446520" y="1600200"/>
+            <a:ext cx="4754880" cy="3154680"/>
           </a:xfrm>
           <a:prstGeom prst="rect">
             <a:avLst/>
@@ -13878,7 +13901,7 @@
           <a:p>
             <a:pPr>
               <a:spcAft>
-                <a:spcPts val="1200"/>
+                <a:spcPts val="800"/>
               </a:spcAft>
               <a:defRPr sz="1400" b="1">
                 <a:solidFill>
@@ -13893,11 +13916,11 @@
           <a:p>
             <a:pPr>
               <a:spcAft>
-                <a:spcPts val="800"/>
+                <a:spcPts val="400"/>
               </a:spcAft>
             </a:pPr>
             <a:r>
-              <a:rPr b="1" sz="1100">
+              <a:rPr b="1" sz="1000">
                 <a:solidFill>
                   <a:srgbClr val="0F2B48"/>
                 </a:solidFill>
@@ -13905,7 +13928,7 @@
               <a:t>⚙ Standby pose: </a:t>
             </a:r>
             <a:r>
-              <a:rPr sz="1100">
+              <a:rPr sz="1000">
                 <a:solidFill>
                   <a:srgbClr val="1E293B"/>
                 </a:solidFill>
@@ -13916,11 +13939,11 @@
           <a:p>
             <a:pPr>
               <a:spcAft>
-                <a:spcPts val="800"/>
+                <a:spcPts val="400"/>
               </a:spcAft>
             </a:pPr>
             <a:r>
-              <a:rPr b="1" sz="1100">
+              <a:rPr b="1" sz="1000">
                 <a:solidFill>
                   <a:srgbClr val="0F2B48"/>
                 </a:solidFill>
@@ -13928,7 +13951,7 @@
               <a:t>⚙ Red bin (left): </a:t>
             </a:r>
             <a:r>
-              <a:rPr sz="1100">
+              <a:rPr sz="1000">
                 <a:solidFill>
                   <a:srgbClr val="1E293B"/>
                 </a:solidFill>
@@ -13939,11 +13962,11 @@
           <a:p>
             <a:pPr>
               <a:spcAft>
-                <a:spcPts val="800"/>
+                <a:spcPts val="400"/>
               </a:spcAft>
             </a:pPr>
             <a:r>
-              <a:rPr b="1" sz="1100">
+              <a:rPr b="1" sz="1000">
                 <a:solidFill>
                   <a:srgbClr val="0F2B48"/>
                 </a:solidFill>
@@ -13951,7 +13974,7 @@
               <a:t>⚙ Yellow bin (right): </a:t>
             </a:r>
             <a:r>
-              <a:rPr sz="1100">
+              <a:rPr sz="1000">
                 <a:solidFill>
                   <a:srgbClr val="1E293B"/>
                 </a:solidFill>
@@ -13962,11 +13985,11 @@
           <a:p>
             <a:pPr>
               <a:spcAft>
-                <a:spcPts val="800"/>
+                <a:spcPts val="400"/>
               </a:spcAft>
             </a:pPr>
             <a:r>
-              <a:rPr b="1" sz="1100">
+              <a:rPr b="1" sz="1000">
                 <a:solidFill>
                   <a:srgbClr val="0F2B48"/>
                 </a:solidFill>
@@ -13974,7 +13997,7 @@
               <a:t>⚙ Blue bin (rear): </a:t>
             </a:r>
             <a:r>
-              <a:rPr sz="1100">
+              <a:rPr sz="1000">
                 <a:solidFill>
                   <a:srgbClr val="1E293B"/>
                 </a:solidFill>
@@ -13985,11 +14008,11 @@
           <a:p>
             <a:pPr>
               <a:spcAft>
-                <a:spcPts val="800"/>
+                <a:spcPts val="400"/>
               </a:spcAft>
             </a:pPr>
             <a:r>
-              <a:rPr b="1" sz="1100">
+              <a:rPr b="1" sz="1000">
                 <a:solidFill>
                   <a:srgbClr val="0F2B48"/>
                 </a:solidFill>
@@ -13997,12 +14020,117 @@
               <a:t>⚙ Kinematic Invariance: </a:t>
             </a:r>
             <a:r>
-              <a:rPr sz="1100">
+              <a:rPr sz="1000">
                 <a:solidFill>
                   <a:srgbClr val="1E293B"/>
                 </a:solidFill>
               </a:rPr>
               <a:t>Shoulder lift, elbow, and wrist joints stay within 0.15 rad across all bins; only shoulder pan swings widely.</a:t>
+            </a:r>
+          </a:p>
+        </p:txBody>
+      </p:sp>
+      <p:sp>
+        <p:nvSpPr>
+          <p:cNvPr id="12" name="Rounded Rectangle 11"/>
+          <p:cNvSpPr/>
+          <p:nvPr/>
+        </p:nvSpPr>
+        <p:spPr>
+          <a:xfrm>
+            <a:off x="731520" y="5120640"/>
+            <a:ext cx="10728655" cy="1051560"/>
+          </a:xfrm>
+          <a:prstGeom prst="roundRect">
+            <a:avLst>
+              <a:gd name="adj" fmla="val 2500"/>
+            </a:avLst>
+          </a:prstGeom>
+          <a:solidFill>
+            <a:srgbClr val="FFFFFF"/>
+          </a:solidFill>
+          <a:ln w="12700">
+            <a:solidFill>
+              <a:srgbClr val="E2E8F0"/>
+            </a:solidFill>
+          </a:ln>
+        </p:spPr>
+        <p:style>
+          <a:lnRef idx="1">
+            <a:schemeClr val="accent1"/>
+          </a:lnRef>
+          <a:fillRef idx="3">
+            <a:schemeClr val="accent1"/>
+          </a:fillRef>
+          <a:effectRef idx="2">
+            <a:schemeClr val="accent1"/>
+          </a:effectRef>
+          <a:fontRef idx="minor">
+            <a:schemeClr val="lt1"/>
+          </a:fontRef>
+        </p:style>
+        <p:txBody>
+          <a:bodyPr rtlCol="0" anchor="ctr"/>
+          <a:lstStyle/>
+          <a:p>
+            <a:pPr algn="ctr"/>
+          </a:p>
+        </p:txBody>
+      </p:sp>
+      <p:sp>
+        <p:nvSpPr>
+          <p:cNvPr id="13" name="TextBox 12"/>
+          <p:cNvSpPr txBox="1"/>
+          <p:nvPr/>
+        </p:nvSpPr>
+        <p:spPr>
+          <a:xfrm>
+            <a:off x="960120" y="5193792"/>
+            <a:ext cx="10241280" cy="896112"/>
+          </a:xfrm>
+          <a:prstGeom prst="rect">
+            <a:avLst/>
+          </a:prstGeom>
+          <a:noFill/>
+        </p:spPr>
+        <p:txBody>
+          <a:bodyPr wrap="square">
+            <a:spAutoFit/>
+          </a:bodyPr>
+          <a:lstStyle/>
+          <a:p>
+            <a:pPr>
+              <a:spcAft>
+                <a:spcPts val="300"/>
+              </a:spcAft>
+              <a:defRPr sz="1200" b="1">
+                <a:solidFill>
+                  <a:srgbClr val="0F2B48"/>
+                </a:solidFill>
+              </a:defRPr>
+            </a:pPr>
+            <a:r>
+              <a:t>INTERACTIVE TRAJECTORY VISUALIZATION &amp; ANTI-CLUTTER TRAIL (HOTKEY [T])</a:t>
+            </a:r>
+          </a:p>
+          <a:p>
+            <a:pPr>
+              <a:defRPr sz="1000">
+                <a:solidFill>
+                  <a:srgbClr val="1E293B"/>
+                </a:solidFill>
+              </a:defRPr>
+            </a:pPr>
+            <a:r>
+              <a:t>• Interactive Toggle [T]: Press [T] during runtime to toggle smooth 3D neon ribbon trail mapped to tool0 end-effector.</a:t>
+            </a:r>
+            <a:br/>
+            <a:r>
+              <a:t>• Anti-Clutter Auto-Fade (3.5s): Automatically fades out tail points after 3.5s, preventing visual clutter across long runs.</a:t>
+            </a:r>
+            <a:br/>
+            <a:r>
+              <a:t>• Color-Coded Target Paths: Dynamically tints trail based on destination bin: Red (#FF2A6D), Yellow (#FFD166), Blue (#05D9E8).</a:t>
             </a:r>
           </a:p>
         </p:txBody>

</xml_diff>